<commit_message>
AutomaTivio: carteira inclui posições sem data; alocação real volta a ser sobre o PL
- Base Carteira: linhas sem data entram junto com as do mês (eram posições
  atuais: no ALT 90 duas cotas sênior e um caixa; no ALT 180, 11 linhas).
- Alocação real sobre o PL, como a planilha da gestão (ALT Light alavancado,
  126%). Setembro fecha com as tabelas: ALT 180 100,3%, ALT 90 100,7%.

Co-Authored-By: Claude Opus 5.5 <noreply@anthropic.com>
</commit_message>
<xml_diff>
--- a/AutomaTivio/saida/2026-09/pptx/Tivio ALT 180 - Relatório de Gestão - Setembro 2026.pptx
+++ b/AutomaTivio/saida/2026-09/pptx/Tivio ALT 180 - Relatório de Gestão - Setembro 2026.pptx
@@ -4657,7 +4657,7 @@
         <p:spPr>
           <a:xfrm>
             <a:off x="498960" y="6275863"/>
-            <a:ext cx="3758501" cy="292477"/>
+            <a:ext cx="3125115" cy="292477"/>
           </a:xfrm>
           <a:prstGeom prst="rect">
             <a:avLst/>
@@ -4710,7 +4710,7 @@
         <p:spPr>
           <a:xfrm>
             <a:off x="498960" y="6573538"/>
-            <a:ext cx="3908841" cy="189000"/>
+            <a:ext cx="3250119" cy="189000"/>
           </a:xfrm>
           <a:prstGeom prst="rect">
             <a:avLst/>
@@ -4733,7 +4733,7 @@
                 </a:solidFill>
                 <a:latin typeface="Versos"/>
               </a:rPr>
-              <a:t>58,5%</a:t>
+              <a:t>49,3%</a:t>
             </a:r>
           </a:p>
         </p:txBody>
@@ -4746,8 +4746,8 @@
         </p:nvSpPr>
         <p:spPr>
           <a:xfrm>
-            <a:off x="4454021" y="6275863"/>
-            <a:ext cx="1196960" cy="292477"/>
+            <a:off x="3820635" y="6275863"/>
+            <a:ext cx="1625281" cy="292477"/>
           </a:xfrm>
           <a:prstGeom prst="rect">
             <a:avLst/>
@@ -4799,8 +4799,8 @@
         </p:nvSpPr>
         <p:spPr>
           <a:xfrm>
-            <a:off x="4454021" y="6573538"/>
-            <a:ext cx="1244839" cy="189000"/>
+            <a:off x="3820635" y="6573538"/>
+            <a:ext cx="1690293" cy="189000"/>
           </a:xfrm>
           <a:prstGeom prst="rect">
             <a:avLst/>
@@ -4823,7 +4823,7 @@
                 </a:solidFill>
                 <a:latin typeface="Versos"/>
               </a:rPr>
-              <a:t>20,6%</a:t>
+              <a:t>27,0%</a:t>
             </a:r>
           </a:p>
         </p:txBody>
@@ -4836,320 +4836,440 @@
         </p:nvSpPr>
         <p:spPr>
           <a:xfrm>
-            <a:off x="5803008" y="6514121"/>
-            <a:ext cx="588451" cy="113400"/>
-          </a:xfrm>
-          <a:prstGeom prst="rect">
-            <a:avLst/>
-          </a:prstGeom>
-          <a:noFill/>
-        </p:spPr>
-        <p:txBody>
-          <a:bodyPr wrap="none" lIns="0" rIns="0" tIns="0" bIns="0" anchor="t"/>
-          <a:lstStyle/>
-          <a:p>
-            <a:pPr algn="l">
-              <a:lnSpc>
-                <a:spcPts val="818"/>
+            <a:off x="5622750" y="5949483"/>
+            <a:ext cx="858967" cy="151200"/>
+          </a:xfrm>
+          <a:prstGeom prst="rect">
+            <a:avLst/>
+          </a:prstGeom>
+          <a:noFill/>
+        </p:spPr>
+        <p:txBody>
+          <a:bodyPr wrap="none" lIns="0" rIns="0" tIns="0" bIns="0" anchor="t"/>
+          <a:lstStyle/>
+          <a:p>
+            <a:pPr algn="l">
+              <a:lnSpc>
+                <a:spcPts val="1113"/>
+              </a:lnSpc>
+            </a:pPr>
+            <a:r>
+              <a:rPr sz="1012" b="0" i="0">
+                <a:solidFill>
+                  <a:srgbClr val="FFFFFF"/>
+                </a:solidFill>
+                <a:latin typeface="Versos"/>
+              </a:rPr>
+              <a:t>Liquidez</a:t>
+            </a:r>
+          </a:p>
+        </p:txBody>
+      </p:sp>
+      <p:sp>
+        <p:nvSpPr>
+          <p:cNvPr id="48" name="TextBox 47"/>
+          <p:cNvSpPr txBox="1"/>
+          <p:nvPr/>
+        </p:nvSpPr>
+        <p:spPr>
+          <a:xfrm>
+            <a:off x="5622750" y="6105881"/>
+            <a:ext cx="858967" cy="189000"/>
+          </a:xfrm>
+          <a:prstGeom prst="rect">
+            <a:avLst/>
+          </a:prstGeom>
+          <a:noFill/>
+        </p:spPr>
+        <p:txBody>
+          <a:bodyPr wrap="none" lIns="0" rIns="0" tIns="0" bIns="0" anchor="t"/>
+          <a:lstStyle/>
+          <a:p>
+            <a:pPr algn="l">
+              <a:lnSpc>
+                <a:spcPts val="1375"/>
+              </a:lnSpc>
+            </a:pPr>
+            <a:r>
+              <a:rPr sz="1250" b="1" i="0">
+                <a:solidFill>
+                  <a:srgbClr val="FFFFFF"/>
+                </a:solidFill>
+                <a:latin typeface="Versos"/>
+              </a:rPr>
+              <a:t>9,1%</a:t>
+            </a:r>
+          </a:p>
+        </p:txBody>
+      </p:sp>
+      <p:sp>
+        <p:nvSpPr>
+          <p:cNvPr id="49" name="TextBox 48"/>
+          <p:cNvSpPr txBox="1"/>
+          <p:nvPr/>
+        </p:nvSpPr>
+        <p:spPr>
+          <a:xfrm>
+            <a:off x="5622750" y="6487425"/>
+            <a:ext cx="858967" cy="98280"/>
+          </a:xfrm>
+          <a:prstGeom prst="rect">
+            <a:avLst/>
+          </a:prstGeom>
+          <a:noFill/>
+        </p:spPr>
+        <p:txBody>
+          <a:bodyPr wrap="none" lIns="0" rIns="0" tIns="0" bIns="0" anchor="t"/>
+          <a:lstStyle/>
+          <a:p>
+            <a:pPr algn="l">
+              <a:lnSpc>
+                <a:spcPts val="713"/>
+              </a:lnSpc>
+            </a:pPr>
+            <a:r>
+              <a:rPr sz="648" b="0" i="0">
+                <a:solidFill>
+                  <a:srgbClr val="2B3744"/>
+                </a:solidFill>
+                <a:latin typeface="Versos"/>
+              </a:rPr>
+              <a:t>Crédito Estruturado</a:t>
+            </a:r>
+          </a:p>
+        </p:txBody>
+      </p:sp>
+      <p:sp>
+        <p:nvSpPr>
+          <p:cNvPr id="50" name="TextBox 49"/>
+          <p:cNvSpPr txBox="1"/>
+          <p:nvPr/>
+        </p:nvSpPr>
+        <p:spPr>
+          <a:xfrm>
+            <a:off x="5622750" y="6593146"/>
+            <a:ext cx="858967" cy="189000"/>
+          </a:xfrm>
+          <a:prstGeom prst="rect">
+            <a:avLst/>
+          </a:prstGeom>
+          <a:noFill/>
+        </p:spPr>
+        <p:txBody>
+          <a:bodyPr wrap="none" lIns="0" rIns="0" tIns="0" bIns="0" anchor="t"/>
+          <a:lstStyle/>
+          <a:p>
+            <a:pPr algn="l">
+              <a:lnSpc>
+                <a:spcPts val="1375"/>
+              </a:lnSpc>
+            </a:pPr>
+            <a:r>
+              <a:rPr sz="1250" b="1" i="0">
+                <a:solidFill>
+                  <a:srgbClr val="2B3744"/>
+                </a:solidFill>
+                <a:latin typeface="Versos"/>
+              </a:rPr>
+              <a:t>5,5%</a:t>
+            </a:r>
+          </a:p>
+        </p:txBody>
+      </p:sp>
+      <p:sp>
+        <p:nvSpPr>
+          <p:cNvPr id="51" name="TextBox 50"/>
+          <p:cNvSpPr txBox="1"/>
+          <p:nvPr/>
+        </p:nvSpPr>
+        <p:spPr>
+          <a:xfrm>
+            <a:off x="6577790" y="5614835"/>
+            <a:ext cx="530853" cy="203056"/>
+          </a:xfrm>
+          <a:prstGeom prst="rect">
+            <a:avLst/>
+          </a:prstGeom>
+          <a:noFill/>
+        </p:spPr>
+        <p:txBody>
+          <a:bodyPr wrap="square" lIns="0" rIns="0" tIns="0" bIns="0" anchor="t"/>
+          <a:lstStyle/>
+          <a:p>
+            <a:pPr algn="l">
+              <a:lnSpc>
+                <a:spcPts val="766"/>
+              </a:lnSpc>
+            </a:pPr>
+            <a:r>
+              <a:rPr sz="696" b="0" i="0">
+                <a:solidFill>
+                  <a:srgbClr val="2B3744"/>
+                </a:solidFill>
+                <a:latin typeface="Versos"/>
+              </a:rPr>
+              <a:t>Crédito</a:t>
+            </a:r>
+          </a:p>
+          <a:p>
+            <a:pPr algn="l">
+              <a:lnSpc>
+                <a:spcPts val="766"/>
+              </a:lnSpc>
+            </a:pPr>
+            <a:r>
+              <a:rPr sz="696" b="1" i="0">
+                <a:solidFill>
+                  <a:srgbClr val="2B3744"/>
+                </a:solidFill>
+                <a:latin typeface="Versos"/>
+              </a:rPr>
+              <a:t>Privado</a:t>
+            </a:r>
+          </a:p>
+        </p:txBody>
+      </p:sp>
+      <p:sp>
+        <p:nvSpPr>
+          <p:cNvPr id="52" name="TextBox 51"/>
+          <p:cNvSpPr txBox="1"/>
+          <p:nvPr/>
+        </p:nvSpPr>
+        <p:spPr>
+          <a:xfrm>
+            <a:off x="6577790" y="5816829"/>
+            <a:ext cx="552087" cy="166320"/>
+          </a:xfrm>
+          <a:prstGeom prst="rect">
+            <a:avLst/>
+          </a:prstGeom>
+          <a:noFill/>
+        </p:spPr>
+        <p:txBody>
+          <a:bodyPr wrap="none" lIns="0" rIns="0" tIns="0" bIns="0" anchor="t"/>
+          <a:lstStyle/>
+          <a:p>
+            <a:pPr algn="l">
+              <a:lnSpc>
+                <a:spcPts val="1178"/>
+              </a:lnSpc>
+            </a:pPr>
+            <a:r>
+              <a:rPr sz="1071" b="1" i="0">
+                <a:solidFill>
+                  <a:srgbClr val="2B3744"/>
+                </a:solidFill>
+                <a:latin typeface="Versos"/>
+              </a:rPr>
+              <a:t>3,4%</a:t>
+            </a:r>
+          </a:p>
+        </p:txBody>
+      </p:sp>
+      <p:sp>
+        <p:nvSpPr>
+          <p:cNvPr id="53" name="TextBox 52"/>
+          <p:cNvSpPr txBox="1"/>
+          <p:nvPr/>
+        </p:nvSpPr>
+        <p:spPr>
+          <a:xfrm>
+            <a:off x="6577790" y="6150532"/>
+            <a:ext cx="552087" cy="105840"/>
+          </a:xfrm>
+          <a:prstGeom prst="rect">
+            <a:avLst/>
+          </a:prstGeom>
+          <a:noFill/>
+        </p:spPr>
+        <p:txBody>
+          <a:bodyPr wrap="none" lIns="0" rIns="0" tIns="0" bIns="0" anchor="t"/>
+          <a:lstStyle/>
+          <a:p>
+            <a:pPr algn="l">
+              <a:lnSpc>
+                <a:spcPts val="766"/>
+              </a:lnSpc>
+            </a:pPr>
+            <a:r>
+              <a:rPr sz="696" b="0" i="0">
+                <a:solidFill>
+                  <a:srgbClr val="2B3744"/>
+                </a:solidFill>
+                <a:latin typeface="Versos"/>
+              </a:rPr>
+              <a:t>Fiagro</a:t>
+            </a:r>
+          </a:p>
+        </p:txBody>
+      </p:sp>
+      <p:sp>
+        <p:nvSpPr>
+          <p:cNvPr id="54" name="TextBox 53"/>
+          <p:cNvSpPr txBox="1"/>
+          <p:nvPr/>
+        </p:nvSpPr>
+        <p:spPr>
+          <a:xfrm>
+            <a:off x="6577790" y="6255309"/>
+            <a:ext cx="552087" cy="166320"/>
+          </a:xfrm>
+          <a:prstGeom prst="rect">
+            <a:avLst/>
+          </a:prstGeom>
+          <a:noFill/>
+        </p:spPr>
+        <p:txBody>
+          <a:bodyPr wrap="none" lIns="0" rIns="0" tIns="0" bIns="0" anchor="t"/>
+          <a:lstStyle/>
+          <a:p>
+            <a:pPr algn="l">
+              <a:lnSpc>
+                <a:spcPts val="1178"/>
+              </a:lnSpc>
+            </a:pPr>
+            <a:r>
+              <a:rPr sz="1071" b="1" i="0">
+                <a:solidFill>
+                  <a:srgbClr val="2B3744"/>
+                </a:solidFill>
+                <a:latin typeface="Versos"/>
+              </a:rPr>
+              <a:t>3,2%</a:t>
+            </a:r>
+          </a:p>
+        </p:txBody>
+      </p:sp>
+      <p:sp>
+        <p:nvSpPr>
+          <p:cNvPr id="55" name="TextBox 54"/>
+          <p:cNvSpPr txBox="1"/>
+          <p:nvPr/>
+        </p:nvSpPr>
+        <p:spPr>
+          <a:xfrm>
+            <a:off x="6577790" y="6542825"/>
+            <a:ext cx="552087" cy="98280"/>
+          </a:xfrm>
+          <a:prstGeom prst="rect">
+            <a:avLst/>
+          </a:prstGeom>
+          <a:noFill/>
+        </p:spPr>
+        <p:txBody>
+          <a:bodyPr wrap="none" lIns="0" rIns="0" tIns="0" bIns="0" anchor="t"/>
+          <a:lstStyle/>
+          <a:p>
+            <a:pPr algn="l">
+              <a:lnSpc>
+                <a:spcPts val="713"/>
+              </a:lnSpc>
+            </a:pPr>
+            <a:r>
+              <a:rPr sz="648" b="0" i="0">
+                <a:solidFill>
+                  <a:srgbClr val="FFFFFF"/>
+                </a:solidFill>
+                <a:latin typeface="Versos"/>
+              </a:rPr>
+              <a:t>Precatório</a:t>
+            </a:r>
+          </a:p>
+        </p:txBody>
+      </p:sp>
+      <p:sp>
+        <p:nvSpPr>
+          <p:cNvPr id="56" name="TextBox 55"/>
+          <p:cNvSpPr txBox="1"/>
+          <p:nvPr/>
+        </p:nvSpPr>
+        <p:spPr>
+          <a:xfrm>
+            <a:off x="6577790" y="6648547"/>
+            <a:ext cx="552087" cy="158760"/>
+          </a:xfrm>
+          <a:prstGeom prst="rect">
+            <a:avLst/>
+          </a:prstGeom>
+          <a:noFill/>
+        </p:spPr>
+        <p:txBody>
+          <a:bodyPr wrap="none" lIns="0" rIns="0" tIns="0" bIns="0" anchor="t"/>
+          <a:lstStyle/>
+          <a:p>
+            <a:pPr algn="l">
+              <a:lnSpc>
+                <a:spcPts val="1159"/>
+              </a:lnSpc>
+            </a:pPr>
+            <a:r>
+              <a:rPr sz="1053" b="1" i="0">
+                <a:solidFill>
+                  <a:srgbClr val="FFFFFF"/>
+                </a:solidFill>
+                <a:latin typeface="Versos"/>
+              </a:rPr>
+              <a:t>2,8%</a:t>
+            </a:r>
+          </a:p>
+        </p:txBody>
+      </p:sp>
+      <p:sp>
+        <p:nvSpPr>
+          <p:cNvPr id="57" name="TextBox 56"/>
+          <p:cNvSpPr txBox="1"/>
+          <p:nvPr/>
+        </p:nvSpPr>
+        <p:spPr>
+          <a:xfrm>
+            <a:off x="529200" y="6929566"/>
+            <a:ext cx="1236116" cy="113400"/>
+          </a:xfrm>
+          <a:prstGeom prst="rect">
+            <a:avLst/>
+          </a:prstGeom>
+          <a:noFill/>
+        </p:spPr>
+        <p:txBody>
+          <a:bodyPr wrap="none" lIns="0" rIns="0" tIns="0" bIns="0" anchor="t"/>
+          <a:lstStyle/>
+          <a:p>
+            <a:pPr algn="l">
+              <a:lnSpc>
+                <a:spcPts val="892"/>
               </a:lnSpc>
             </a:pPr>
             <a:r>
               <a:rPr sz="744" b="0" i="0">
                 <a:solidFill>
-                  <a:srgbClr val="FFFFFF"/>
-                </a:solidFill>
-                <a:latin typeface="Versos"/>
-              </a:rPr>
-              <a:t>Liquidez</a:t>
-            </a:r>
-          </a:p>
-        </p:txBody>
-      </p:sp>
-      <p:sp>
-        <p:nvSpPr>
-          <p:cNvPr id="48" name="TextBox 47"/>
-          <p:cNvSpPr txBox="1"/>
-          <p:nvPr/>
-        </p:nvSpPr>
-        <p:spPr>
-          <a:xfrm>
-            <a:off x="5803008" y="6633191"/>
-            <a:ext cx="588451" cy="173880"/>
-          </a:xfrm>
-          <a:prstGeom prst="rect">
-            <a:avLst/>
-          </a:prstGeom>
-          <a:noFill/>
-        </p:spPr>
-        <p:txBody>
-          <a:bodyPr wrap="none" lIns="0" rIns="0" tIns="0" bIns="0" anchor="t"/>
-          <a:lstStyle/>
-          <a:p>
-            <a:pPr algn="l">
-              <a:lnSpc>
-                <a:spcPts val="1257"/>
-              </a:lnSpc>
-            </a:pPr>
-            <a:r>
-              <a:rPr sz="1142" b="1" i="0">
-                <a:solidFill>
-                  <a:srgbClr val="FFFFFF"/>
-                </a:solidFill>
-                <a:latin typeface="Versos"/>
-              </a:rPr>
-              <a:t>10,0%</a:t>
-            </a:r>
-          </a:p>
-        </p:txBody>
-      </p:sp>
-      <p:sp>
-        <p:nvSpPr>
-          <p:cNvPr id="49" name="TextBox 48"/>
-          <p:cNvSpPr txBox="1"/>
-          <p:nvPr/>
-        </p:nvSpPr>
-        <p:spPr>
-          <a:xfrm>
-            <a:off x="6481518" y="5579988"/>
-            <a:ext cx="618738" cy="234005"/>
-          </a:xfrm>
-          <a:prstGeom prst="rect">
-            <a:avLst/>
-          </a:prstGeom>
-          <a:noFill/>
-        </p:spPr>
-        <p:txBody>
-          <a:bodyPr wrap="square" lIns="0" rIns="0" tIns="0" bIns="0" anchor="t"/>
-          <a:lstStyle/>
-          <a:p>
-            <a:pPr algn="l">
-              <a:lnSpc>
-                <a:spcPts val="890"/>
-              </a:lnSpc>
-            </a:pPr>
-            <a:r>
-              <a:rPr sz="809" b="0" i="0">
-                <a:solidFill>
-                  <a:srgbClr val="2B3744"/>
-                </a:solidFill>
-                <a:latin typeface="Versos"/>
-              </a:rPr>
-              <a:t>Crédito</a:t>
-            </a:r>
-          </a:p>
-          <a:p>
-            <a:pPr algn="l">
-              <a:lnSpc>
-                <a:spcPts val="890"/>
-              </a:lnSpc>
-            </a:pPr>
-            <a:r>
-              <a:rPr sz="809" b="1" i="0">
-                <a:solidFill>
-                  <a:srgbClr val="2B3744"/>
-                </a:solidFill>
-                <a:latin typeface="Versos"/>
-              </a:rPr>
-              <a:t>Privado</a:t>
-            </a:r>
-          </a:p>
-        </p:txBody>
-      </p:sp>
-      <p:sp>
-        <p:nvSpPr>
-          <p:cNvPr id="50" name="TextBox 49"/>
-          <p:cNvSpPr txBox="1"/>
-          <p:nvPr/>
-        </p:nvSpPr>
-        <p:spPr>
-          <a:xfrm>
-            <a:off x="6481518" y="5821200"/>
-            <a:ext cx="643488" cy="189000"/>
-          </a:xfrm>
-          <a:prstGeom prst="rect">
-            <a:avLst/>
-          </a:prstGeom>
-          <a:noFill/>
-        </p:spPr>
-        <p:txBody>
-          <a:bodyPr wrap="none" lIns="0" rIns="0" tIns="0" bIns="0" anchor="t"/>
-          <a:lstStyle/>
-          <a:p>
-            <a:pPr algn="l">
-              <a:lnSpc>
-                <a:spcPts val="1375"/>
-              </a:lnSpc>
-            </a:pPr>
-            <a:r>
-              <a:rPr sz="1250" b="1" i="0">
-                <a:solidFill>
-                  <a:srgbClr val="2B3744"/>
-                </a:solidFill>
-                <a:latin typeface="Versos"/>
-              </a:rPr>
-              <a:t>4,2%</a:t>
-            </a:r>
-          </a:p>
-        </p:txBody>
-      </p:sp>
-      <p:sp>
-        <p:nvSpPr>
-          <p:cNvPr id="51" name="TextBox 50"/>
-          <p:cNvSpPr txBox="1"/>
-          <p:nvPr/>
-        </p:nvSpPr>
-        <p:spPr>
-          <a:xfrm>
-            <a:off x="6481518" y="6162108"/>
-            <a:ext cx="643488" cy="120960"/>
-          </a:xfrm>
-          <a:prstGeom prst="rect">
-            <a:avLst/>
-          </a:prstGeom>
-          <a:noFill/>
-        </p:spPr>
-        <p:txBody>
-          <a:bodyPr wrap="none" lIns="0" rIns="0" tIns="0" bIns="0" anchor="t"/>
-          <a:lstStyle/>
-          <a:p>
-            <a:pPr algn="l">
-              <a:lnSpc>
-                <a:spcPts val="870"/>
-              </a:lnSpc>
-            </a:pPr>
-            <a:r>
-              <a:rPr sz="791" b="0" i="0">
-                <a:solidFill>
-                  <a:srgbClr val="2B3744"/>
-                </a:solidFill>
-                <a:latin typeface="Versos"/>
-              </a:rPr>
-              <a:t>Fiagro</a:t>
-            </a:r>
-          </a:p>
-        </p:txBody>
-      </p:sp>
-      <p:sp>
-        <p:nvSpPr>
-          <p:cNvPr id="52" name="TextBox 51"/>
-          <p:cNvSpPr txBox="1"/>
-          <p:nvPr/>
-        </p:nvSpPr>
-        <p:spPr>
-          <a:xfrm>
-            <a:off x="6481518" y="6287793"/>
-            <a:ext cx="643488" cy="189000"/>
-          </a:xfrm>
-          <a:prstGeom prst="rect">
-            <a:avLst/>
-          </a:prstGeom>
-          <a:noFill/>
-        </p:spPr>
-        <p:txBody>
-          <a:bodyPr wrap="none" lIns="0" rIns="0" tIns="0" bIns="0" anchor="t"/>
-          <a:lstStyle/>
-          <a:p>
-            <a:pPr algn="l">
-              <a:lnSpc>
-                <a:spcPts val="1375"/>
-              </a:lnSpc>
-            </a:pPr>
-            <a:r>
-              <a:rPr sz="1250" b="1" i="0">
-                <a:solidFill>
-                  <a:srgbClr val="2B3744"/>
-                </a:solidFill>
-                <a:latin typeface="Versos"/>
-              </a:rPr>
-              <a:t>3,9%</a:t>
-            </a:r>
-          </a:p>
-        </p:txBody>
-      </p:sp>
-      <p:sp>
-        <p:nvSpPr>
-          <p:cNvPr id="53" name="TextBox 52"/>
-          <p:cNvSpPr txBox="1"/>
-          <p:nvPr/>
-        </p:nvSpPr>
-        <p:spPr>
-          <a:xfrm>
-            <a:off x="6481518" y="6571057"/>
-            <a:ext cx="643488" cy="83160"/>
-          </a:xfrm>
-          <a:prstGeom prst="rect">
-            <a:avLst/>
-          </a:prstGeom>
-          <a:noFill/>
-        </p:spPr>
-        <p:txBody>
-          <a:bodyPr wrap="none" lIns="0" rIns="0" tIns="0" bIns="0" anchor="t"/>
-          <a:lstStyle/>
-          <a:p>
-            <a:pPr algn="l">
-              <a:lnSpc>
-                <a:spcPts val="602"/>
-              </a:lnSpc>
-            </a:pPr>
-            <a:r>
-              <a:rPr sz="547" b="0" i="0">
-                <a:solidFill>
-                  <a:srgbClr val="2B3744"/>
-                </a:solidFill>
-                <a:latin typeface="Versos"/>
-              </a:rPr>
-              <a:t>Precatório</a:t>
-            </a:r>
-          </a:p>
-        </p:txBody>
-      </p:sp>
-      <p:sp>
-        <p:nvSpPr>
-          <p:cNvPr id="54" name="TextBox 53"/>
-          <p:cNvSpPr txBox="1"/>
-          <p:nvPr/>
-        </p:nvSpPr>
-        <p:spPr>
-          <a:xfrm>
-            <a:off x="6481518" y="6662604"/>
-            <a:ext cx="643488" cy="136080"/>
-          </a:xfrm>
-          <a:prstGeom prst="rect">
-            <a:avLst/>
-          </a:prstGeom>
-          <a:noFill/>
-        </p:spPr>
-        <p:txBody>
-          <a:bodyPr wrap="none" lIns="0" rIns="0" tIns="0" bIns="0" anchor="t"/>
-          <a:lstStyle/>
-          <a:p>
-            <a:pPr algn="l">
-              <a:lnSpc>
-                <a:spcPts val="982"/>
-              </a:lnSpc>
-            </a:pPr>
-            <a:r>
-              <a:rPr sz="892" b="1" i="0">
-                <a:solidFill>
-                  <a:srgbClr val="2B3744"/>
-                </a:solidFill>
-                <a:latin typeface="Versos"/>
-              </a:rPr>
-              <a:t>2,7%</a:t>
-            </a:r>
-          </a:p>
-        </p:txBody>
-      </p:sp>
-      <p:sp>
-        <p:nvSpPr>
-          <p:cNvPr id="55" name="TextBox 54"/>
-          <p:cNvSpPr txBox="1"/>
-          <p:nvPr/>
-        </p:nvSpPr>
-        <p:spPr>
-          <a:xfrm>
-            <a:off x="529200" y="6929566"/>
-            <a:ext cx="1231325" cy="113400"/>
+                  <a:srgbClr val="333333"/>
+                </a:solidFill>
+                <a:latin typeface="Versos"/>
+              </a:rPr>
+              <a:t>FIDCs Cota Sênior </a:t>
+            </a:r>
+            <a:r>
+              <a:rPr sz="744" b="1" i="0">
+                <a:solidFill>
+                  <a:srgbClr val="111111"/>
+                </a:solidFill>
+                <a:latin typeface="Versos"/>
+              </a:rPr>
+              <a:t>49,3%</a:t>
+            </a:r>
+          </a:p>
+        </p:txBody>
+      </p:sp>
+      <p:sp>
+        <p:nvSpPr>
+          <p:cNvPr id="58" name="TextBox 57"/>
+          <p:cNvSpPr txBox="1"/>
+          <p:nvPr/>
+        </p:nvSpPr>
+        <p:spPr>
+          <a:xfrm>
+            <a:off x="1982373" y="6929566"/>
+            <a:ext cx="1368426" cy="113400"/>
           </a:xfrm>
           <a:prstGeom prst="rect">
             <a:avLst/>
@@ -5172,7 +5292,7 @@
                 </a:solidFill>
                 <a:latin typeface="Versos"/>
               </a:rPr>
-              <a:t>FIDCs Cota Sênior </a:t>
+              <a:t>FIDCs Cota Mezanino </a:t>
             </a:r>
             <a:r>
               <a:rPr sz="744" b="1" i="0">
@@ -5181,21 +5301,21 @@
                 </a:solidFill>
                 <a:latin typeface="Versos"/>
               </a:rPr>
-              <a:t>58,5%</a:t>
-            </a:r>
-          </a:p>
-        </p:txBody>
-      </p:sp>
-      <p:sp>
-        <p:nvSpPr>
-          <p:cNvPr id="56" name="TextBox 55"/>
-          <p:cNvSpPr txBox="1"/>
-          <p:nvPr/>
-        </p:nvSpPr>
-        <p:spPr>
-          <a:xfrm>
-            <a:off x="1977766" y="6929566"/>
-            <a:ext cx="1382185" cy="113400"/>
+              <a:t>27,0%</a:t>
+            </a:r>
+          </a:p>
+        </p:txBody>
+      </p:sp>
+      <p:sp>
+        <p:nvSpPr>
+          <p:cNvPr id="59" name="TextBox 58"/>
+          <p:cNvSpPr txBox="1"/>
+          <p:nvPr/>
+        </p:nvSpPr>
+        <p:spPr>
+          <a:xfrm>
+            <a:off x="3562768" y="6929566"/>
+            <a:ext cx="657984" cy="113400"/>
           </a:xfrm>
           <a:prstGeom prst="rect">
             <a:avLst/>
@@ -5218,7 +5338,7 @@
                 </a:solidFill>
                 <a:latin typeface="Versos"/>
               </a:rPr>
-              <a:t>FIDCs Cota Mezanino </a:t>
+              <a:t>Liquidez </a:t>
             </a:r>
             <a:r>
               <a:rPr sz="744" b="1" i="0">
@@ -5227,21 +5347,21 @@
                 </a:solidFill>
                 <a:latin typeface="Versos"/>
               </a:rPr>
-              <a:t>20,6%</a:t>
-            </a:r>
-          </a:p>
-        </p:txBody>
-      </p:sp>
-      <p:sp>
-        <p:nvSpPr>
-          <p:cNvPr id="57" name="TextBox 56"/>
-          <p:cNvSpPr txBox="1"/>
-          <p:nvPr/>
-        </p:nvSpPr>
-        <p:spPr>
-          <a:xfrm>
-            <a:off x="3571391" y="6929566"/>
-            <a:ext cx="731694" cy="113400"/>
+              <a:t>9,1%</a:t>
+            </a:r>
+          </a:p>
+        </p:txBody>
+      </p:sp>
+      <p:sp>
+        <p:nvSpPr>
+          <p:cNvPr id="60" name="TextBox 59"/>
+          <p:cNvSpPr txBox="1"/>
+          <p:nvPr/>
+        </p:nvSpPr>
+        <p:spPr>
+          <a:xfrm>
+            <a:off x="4460045" y="6929566"/>
+            <a:ext cx="1217689" cy="113400"/>
           </a:xfrm>
           <a:prstGeom prst="rect">
             <a:avLst/>
@@ -5264,7 +5384,7 @@
                 </a:solidFill>
                 <a:latin typeface="Versos"/>
               </a:rPr>
-              <a:t>Liquidez </a:t>
+              <a:t>Crédito Estruturado </a:t>
             </a:r>
             <a:r>
               <a:rPr sz="744" b="1" i="0">
@@ -5273,21 +5393,21 @@
                 </a:solidFill>
                 <a:latin typeface="Versos"/>
               </a:rPr>
-              <a:t>10,0%</a:t>
-            </a:r>
-          </a:p>
-        </p:txBody>
-      </p:sp>
-      <p:sp>
-        <p:nvSpPr>
-          <p:cNvPr id="58" name="TextBox 57"/>
-          <p:cNvSpPr txBox="1"/>
-          <p:nvPr/>
-        </p:nvSpPr>
-        <p:spPr>
-          <a:xfrm>
-            <a:off x="4539543" y="6929566"/>
-            <a:ext cx="1024077" cy="113400"/>
+              <a:t>5,5%</a:t>
+            </a:r>
+          </a:p>
+        </p:txBody>
+      </p:sp>
+      <p:sp>
+        <p:nvSpPr>
+          <p:cNvPr id="61" name="TextBox 60"/>
+          <p:cNvSpPr txBox="1"/>
+          <p:nvPr/>
+        </p:nvSpPr>
+        <p:spPr>
+          <a:xfrm>
+            <a:off x="5895500" y="6929566"/>
+            <a:ext cx="1019532" cy="113400"/>
           </a:xfrm>
           <a:prstGeom prst="rect">
             <a:avLst/>
@@ -5319,21 +5439,21 @@
                 </a:solidFill>
                 <a:latin typeface="Versos"/>
               </a:rPr>
-              <a:t>4,2%</a:t>
-            </a:r>
-          </a:p>
-        </p:txBody>
-      </p:sp>
-      <p:sp>
-        <p:nvSpPr>
-          <p:cNvPr id="59" name="TextBox 58"/>
-          <p:cNvSpPr txBox="1"/>
-          <p:nvPr/>
-        </p:nvSpPr>
-        <p:spPr>
-          <a:xfrm>
-            <a:off x="5788833" y="6929566"/>
-            <a:ext cx="586363" cy="113400"/>
+              <a:t>3,4%</a:t>
+            </a:r>
+          </a:p>
+        </p:txBody>
+      </p:sp>
+      <p:sp>
+        <p:nvSpPr>
+          <p:cNvPr id="62" name="TextBox 61"/>
+          <p:cNvSpPr txBox="1"/>
+          <p:nvPr/>
+        </p:nvSpPr>
+        <p:spPr>
+          <a:xfrm>
+            <a:off x="529200" y="7088326"/>
+            <a:ext cx="585503" cy="113400"/>
           </a:xfrm>
           <a:prstGeom prst="rect">
             <a:avLst/>
@@ -5365,21 +5485,21 @@
                 </a:solidFill>
                 <a:latin typeface="Versos"/>
               </a:rPr>
-              <a:t>3,9%</a:t>
-            </a:r>
-          </a:p>
-        </p:txBody>
-      </p:sp>
-      <p:sp>
-        <p:nvSpPr>
-          <p:cNvPr id="60" name="TextBox 59"/>
-          <p:cNvSpPr txBox="1"/>
-          <p:nvPr/>
-        </p:nvSpPr>
-        <p:spPr>
-          <a:xfrm>
-            <a:off x="529200" y="7088326"/>
-            <a:ext cx="776657" cy="113400"/>
+              <a:t>3,2%</a:t>
+            </a:r>
+          </a:p>
+        </p:txBody>
+      </p:sp>
+      <p:sp>
+        <p:nvSpPr>
+          <p:cNvPr id="63" name="TextBox 62"/>
+          <p:cNvSpPr txBox="1"/>
+          <p:nvPr/>
+        </p:nvSpPr>
+        <p:spPr>
+          <a:xfrm>
+            <a:off x="1356783" y="7088326"/>
+            <a:ext cx="784520" cy="113400"/>
           </a:xfrm>
           <a:prstGeom prst="rect">
             <a:avLst/>
@@ -5411,14 +5531,14 @@
                 </a:solidFill>
                 <a:latin typeface="Versos"/>
               </a:rPr>
-              <a:t>2,7%</a:t>
-            </a:r>
-          </a:p>
-        </p:txBody>
-      </p:sp>
-      <p:sp>
-        <p:nvSpPr>
-          <p:cNvPr id="61" name="TextBox 60"/>
+              <a:t>2,8%</a:t>
+            </a:r>
+          </a:p>
+        </p:txBody>
+      </p:sp>
+      <p:sp>
+        <p:nvSpPr>
+          <p:cNvPr id="64" name="TextBox 63"/>
           <p:cNvSpPr txBox="1"/>
           <p:nvPr/>
         </p:nvSpPr>
@@ -5455,7 +5575,7 @@
       </p:sp>
       <p:sp>
         <p:nvSpPr>
-          <p:cNvPr id="62" name="TextBox 61"/>
+          <p:cNvPr id="65" name="TextBox 64"/>
           <p:cNvSpPr txBox="1"/>
           <p:nvPr/>
         </p:nvSpPr>
@@ -5492,7 +5612,7 @@
       </p:sp>
       <p:sp>
         <p:nvSpPr>
-          <p:cNvPr id="63" name="TextBox 62"/>
+          <p:cNvPr id="66" name="TextBox 65"/>
           <p:cNvSpPr txBox="1"/>
           <p:nvPr/>
         </p:nvSpPr>
@@ -5529,7 +5649,7 @@
       </p:sp>
       <p:sp>
         <p:nvSpPr>
-          <p:cNvPr id="64" name="TextBox 63"/>
+          <p:cNvPr id="67" name="TextBox 66"/>
           <p:cNvSpPr txBox="1"/>
           <p:nvPr/>
         </p:nvSpPr>
@@ -5566,7 +5686,7 @@
       </p:sp>
       <p:sp>
         <p:nvSpPr>
-          <p:cNvPr id="65" name="TextBox 64"/>
+          <p:cNvPr id="68" name="TextBox 67"/>
           <p:cNvSpPr txBox="1"/>
           <p:nvPr/>
         </p:nvSpPr>
@@ -5763,7 +5883,7 @@
         <p:spPr>
           <a:xfrm>
             <a:off x="3217488" y="1623037"/>
-            <a:ext cx="467567" cy="143640"/>
+            <a:ext cx="432186" cy="143640"/>
           </a:xfrm>
           <a:prstGeom prst="rect">
             <a:avLst/>
@@ -5786,7 +5906,7 @@
                 </a:solidFill>
                 <a:latin typeface="Versos"/>
               </a:rPr>
-              <a:t>20,90%</a:t>
+              <a:t>30,61%</a:t>
             </a:r>
           </a:p>
         </p:txBody>
@@ -5836,8 +5956,8 @@
         </p:nvSpPr>
         <p:spPr>
           <a:xfrm>
-            <a:off x="2893708" y="1880077"/>
-            <a:ext cx="427640" cy="143640"/>
+            <a:off x="2638558" y="1880077"/>
+            <a:ext cx="411301" cy="143640"/>
           </a:xfrm>
           <a:prstGeom prst="rect">
             <a:avLst/>
@@ -5860,7 +5980,7 @@
                 </a:solidFill>
                 <a:latin typeface="Versos"/>
               </a:rPr>
-              <a:t>15,22%</a:t>
+              <a:t>15,74%</a:t>
             </a:r>
           </a:p>
         </p:txBody>
@@ -5910,7 +6030,7 @@
         </p:nvSpPr>
         <p:spPr>
           <a:xfrm>
-            <a:off x="2386006" y="2137117"/>
+            <a:off x="2271780" y="2137117"/>
             <a:ext cx="353070" cy="143640"/>
           </a:xfrm>
           <a:prstGeom prst="rect">
@@ -5984,7 +6104,7 @@
         </p:nvSpPr>
         <p:spPr>
           <a:xfrm>
-            <a:off x="2374785" y="2394157"/>
+            <a:off x="2264220" y="2394157"/>
             <a:ext cx="344839" cy="143640"/>
           </a:xfrm>
           <a:prstGeom prst="rect">
@@ -6058,7 +6178,7 @@
         </p:nvSpPr>
         <p:spPr>
           <a:xfrm>
-            <a:off x="2346671" y="2651197"/>
+            <a:off x="2244965" y="2651197"/>
             <a:ext cx="380712" cy="143640"/>
           </a:xfrm>
           <a:prstGeom prst="rect">
@@ -6095,16 +6215,16 @@
         </p:nvSpPr>
         <p:spPr>
           <a:xfrm>
-            <a:off x="400680" y="2859451"/>
-            <a:ext cx="1481760" cy="234005"/>
-          </a:xfrm>
-          <a:prstGeom prst="rect">
-            <a:avLst/>
-          </a:prstGeom>
-          <a:noFill/>
-        </p:spPr>
-        <p:txBody>
-          <a:bodyPr wrap="square" lIns="0" rIns="0" tIns="0" bIns="0" anchor="t"/>
+            <a:off x="400680" y="2915915"/>
+            <a:ext cx="1541030" cy="120960"/>
+          </a:xfrm>
+          <a:prstGeom prst="rect">
+            <a:avLst/>
+          </a:prstGeom>
+          <a:noFill/>
+        </p:spPr>
+        <p:txBody>
+          <a:bodyPr wrap="none" lIns="0" rIns="0" tIns="0" bIns="0" anchor="t"/>
           <a:lstStyle/>
           <a:p>
             <a:pPr algn="r">
@@ -6119,7 +6239,7 @@
                 </a:solidFill>
                 <a:latin typeface="Versos"/>
               </a:rPr>
-              <a:t>Comércio atacadista e varejista</a:t>
+              <a:t>Açúcar, Álcool e Cana</a:t>
             </a:r>
           </a:p>
         </p:txBody>
@@ -6132,8 +6252,8 @@
         </p:nvSpPr>
         <p:spPr>
           <a:xfrm>
-            <a:off x="2294696" y="2908237"/>
-            <a:ext cx="350982" cy="143640"/>
+            <a:off x="2239413" y="2908237"/>
+            <a:ext cx="391277" cy="143640"/>
           </a:xfrm>
           <a:prstGeom prst="rect">
             <a:avLst/>
@@ -6156,7 +6276,7 @@
                 </a:solidFill>
                 <a:latin typeface="Versos"/>
               </a:rPr>
-              <a:t>4,71%</a:t>
+              <a:t>5,48%</a:t>
             </a:r>
           </a:p>
         </p:txBody>
@@ -6206,8 +6326,8 @@
         </p:nvSpPr>
         <p:spPr>
           <a:xfrm>
-            <a:off x="2262684" y="3165277"/>
-            <a:ext cx="346805" cy="143640"/>
+            <a:off x="2228073" y="3165277"/>
+            <a:ext cx="348402" cy="143640"/>
           </a:xfrm>
           <a:prstGeom prst="rect">
             <a:avLst/>
@@ -6230,7 +6350,7 @@
                 </a:solidFill>
                 <a:latin typeface="Versos"/>
               </a:rPr>
-              <a:t>4,15%</a:t>
+              <a:t>5,19%</a:t>
             </a:r>
           </a:p>
         </p:txBody>
@@ -6243,16 +6363,16 @@
         </p:nvSpPr>
         <p:spPr>
           <a:xfrm>
-            <a:off x="400680" y="3429995"/>
-            <a:ext cx="1541030" cy="120960"/>
-          </a:xfrm>
-          <a:prstGeom prst="rect">
-            <a:avLst/>
-          </a:prstGeom>
-          <a:noFill/>
-        </p:spPr>
-        <p:txBody>
-          <a:bodyPr wrap="none" lIns="0" rIns="0" tIns="0" bIns="0" anchor="t"/>
+            <a:off x="400680" y="3373531"/>
+            <a:ext cx="1481760" cy="234005"/>
+          </a:xfrm>
+          <a:prstGeom prst="rect">
+            <a:avLst/>
+          </a:prstGeom>
+          <a:noFill/>
+        </p:spPr>
+        <p:txBody>
+          <a:bodyPr wrap="square" lIns="0" rIns="0" tIns="0" bIns="0" anchor="t"/>
           <a:lstStyle/>
           <a:p>
             <a:pPr algn="r">
@@ -6267,7 +6387,7 @@
                 </a:solidFill>
                 <a:latin typeface="Versos"/>
               </a:rPr>
-              <a:t>Serviços Imobiliários</a:t>
+              <a:t>Comércio atacadista e varejista</a:t>
             </a:r>
           </a:p>
         </p:txBody>
@@ -6280,8 +6400,8 @@
         </p:nvSpPr>
         <p:spPr>
           <a:xfrm>
-            <a:off x="2225829" y="3422317"/>
-            <a:ext cx="348894" cy="143640"/>
+            <a:off x="2209528" y="3422317"/>
+            <a:ext cx="350982" cy="143640"/>
           </a:xfrm>
           <a:prstGeom prst="rect">
             <a:avLst/>
@@ -6304,7 +6424,7 @@
                 </a:solidFill>
                 <a:latin typeface="Versos"/>
               </a:rPr>
-              <a:t>3,51%</a:t>
+              <a:t>4,71%</a:t>
             </a:r>
           </a:p>
         </p:txBody>
@@ -6341,7 +6461,7 @@
                 </a:solidFill>
                 <a:latin typeface="Versos"/>
               </a:rPr>
-              <a:t>TI e Telecomunicações</a:t>
+              <a:t>Serviços Imobiliários</a:t>
             </a:r>
           </a:p>
         </p:txBody>
@@ -6354,8 +6474,8 @@
         </p:nvSpPr>
         <p:spPr>
           <a:xfrm>
-            <a:off x="2222167" y="3679357"/>
-            <a:ext cx="385749" cy="143640"/>
+            <a:off x="2162396" y="3679357"/>
+            <a:ext cx="348894" cy="143640"/>
           </a:xfrm>
           <a:prstGeom prst="rect">
             <a:avLst/>
@@ -6378,7 +6498,7 @@
                 </a:solidFill>
                 <a:latin typeface="Versos"/>
               </a:rPr>
-              <a:t>3,44%</a:t>
+              <a:t>3,51%</a:t>
             </a:r>
           </a:p>
         </p:txBody>
@@ -6415,7 +6535,7 @@
                 </a:solidFill>
                 <a:latin typeface="Versos"/>
               </a:rPr>
-              <a:t>Agrícola</a:t>
+              <a:t>TI e Telecomunicações</a:t>
             </a:r>
           </a:p>
         </p:txBody>
@@ -6428,8 +6548,8 @@
         </p:nvSpPr>
         <p:spPr>
           <a:xfrm>
-            <a:off x="2206811" y="3936397"/>
-            <a:ext cx="341031" cy="143640"/>
+            <a:off x="2159915" y="3936397"/>
+            <a:ext cx="385749" cy="143640"/>
           </a:xfrm>
           <a:prstGeom prst="rect">
             <a:avLst/>
@@ -6452,7 +6572,7 @@
                 </a:solidFill>
                 <a:latin typeface="Versos"/>
               </a:rPr>
-              <a:t>3,17%</a:t>
+              <a:t>3,44%</a:t>
             </a:r>
           </a:p>
         </p:txBody>
@@ -6489,7 +6609,7 @@
                 </a:solidFill>
                 <a:latin typeface="Versos"/>
               </a:rPr>
-              <a:t>Outros</a:t>
+              <a:t>Agrícola</a:t>
             </a:r>
           </a:p>
         </p:txBody>
@@ -6502,8 +6622,8 @@
         </p:nvSpPr>
         <p:spPr>
           <a:xfrm>
-            <a:off x="2175390" y="4193437"/>
-            <a:ext cx="380343" cy="143640"/>
+            <a:off x="2149520" y="4193437"/>
+            <a:ext cx="341031" cy="143640"/>
           </a:xfrm>
           <a:prstGeom prst="rect">
             <a:avLst/>
@@ -6526,7 +6646,7 @@
                 </a:solidFill>
                 <a:latin typeface="Versos"/>
               </a:rPr>
-              <a:t>2,62%</a:t>
+              <a:t>3,17%</a:t>
             </a:r>
           </a:p>
         </p:txBody>
@@ -6563,7 +6683,7 @@
                 </a:solidFill>
                 <a:latin typeface="Versos"/>
               </a:rPr>
-              <a:t>Transporte e Logística</a:t>
+              <a:t>Educação</a:t>
             </a:r>
           </a:p>
         </p:txBody>
@@ -6576,8 +6696,8 @@
         </p:nvSpPr>
         <p:spPr>
           <a:xfrm>
-            <a:off x="2166058" y="4450477"/>
-            <a:ext cx="389557" cy="143640"/>
+            <a:off x="2133691" y="4450477"/>
+            <a:ext cx="370761" cy="143640"/>
           </a:xfrm>
           <a:prstGeom prst="rect">
             <a:avLst/>
@@ -6600,7 +6720,7 @@
                 </a:solidFill>
                 <a:latin typeface="Versos"/>
               </a:rPr>
-              <a:t>2,46%</a:t>
+              <a:t>2,77%</a:t>
             </a:r>
           </a:p>
         </p:txBody>

</xml_diff>